<commit_message>
Renomeia Dump para Uteis e adiciona scripts de geracao de slides
Claude-Session: https://claude.ai/code/session_017RpggrWKEDvAziUgEdUDju
</commit_message>
<xml_diff>
--- a/Semis/KAIROS_semifinal.pptx
+++ b/Semis/KAIROS_semifinal.pptx
@@ -5,7 +5,7 @@
     <p:sldMasterId id="2147483648" r:id="rId1"/>
   </p:sldMasterIdLst>
   <p:notesMasterIdLst>
-    <p:notesMasterId r:id="rId10"/>
+    <p:notesMasterId r:id="rId11"/>
   </p:notesMasterIdLst>
   <p:sldIdLst>
     <p:sldId id="256" r:id="rId2"/>
@@ -16,7 +16,7 @@
     <p:sldId id="261" r:id="rId7"/>
     <p:sldId id="262" r:id="rId8"/>
     <p:sldId id="263" r:id="rId9"/>
-    <p:sldId id="267" r:id="rId16"/>
+    <p:sldId id="267" r:id="rId10"/>
   </p:sldIdLst>
   <p:sldSz cx="12192000" cy="6858000"/>
   <p:notesSz cx="6858000" cy="9144000"/>
@@ -226,7 +226,7 @@
           <a:p>
             <a:fld id="{F3B5C461-9D63-4A58-BF91-933D95097AE6}" type="datetimeFigureOut">
               <a:rPr lang="pt-BR" smtClean="0"/>
-              <a:t>06/09/2026</a:t>
+              <a:t>08/09/2026</a:t>
             </a:fld>
             <a:endParaRPr lang="pt-BR"/>
           </a:p>
@@ -384,7 +384,7 @@
           <a:p>
             <a:fld id="{9F6ADDB9-189E-4F84-A208-07C1AA8F3A13}" type="slidenum">
               <a:rPr lang="pt-BR" smtClean="0"/>
-              <a:t>‹#›</a:t>
+              <a:t>‹nº›</a:t>
             </a:fld>
             <a:endParaRPr lang="pt-BR"/>
           </a:p>
@@ -1181,7 +1181,7 @@
           <a:p>
             <a:fld id="{9F6ADDB9-189E-4F84-A208-07C1AA8F3A13}" type="slidenum">
               <a:rPr lang="pt-BR" smtClean="0"/>
-              <a:t>10</a:t>
+              <a:t>8</a:t>
             </a:fld>
             <a:endParaRPr lang="pt-BR"/>
           </a:p>
@@ -1379,7 +1379,7 @@
           <a:p>
             <a:fld id="{5BCAD085-E8A6-8845-BD4E-CB4CCA059FC4}" type="datetimeFigureOut">
               <a:rPr lang="en-US" smtClean="0"/>
-              <a:t>9/6/2026</a:t>
+              <a:t>9/8/2026</a:t>
             </a:fld>
             <a:endParaRPr lang="en-US"/>
           </a:p>
@@ -1421,7 +1421,7 @@
           <a:p>
             <a:fld id="{C1FF6DA9-008F-8B48-92A6-B652298478BF}" type="slidenum">
               <a:rPr lang="en-US" smtClean="0"/>
-              <a:t>‹#›</a:t>
+              <a:t>‹nº›</a:t>
             </a:fld>
             <a:endParaRPr lang="en-US"/>
           </a:p>
@@ -1547,7 +1547,7 @@
           <a:p>
             <a:fld id="{5BCAD085-E8A6-8845-BD4E-CB4CCA059FC4}" type="datetimeFigureOut">
               <a:rPr lang="en-US" smtClean="0"/>
-              <a:t>9/6/2026</a:t>
+              <a:t>9/8/2026</a:t>
             </a:fld>
             <a:endParaRPr lang="en-US"/>
           </a:p>
@@ -1589,7 +1589,7 @@
           <a:p>
             <a:fld id="{C1FF6DA9-008F-8B48-92A6-B652298478BF}" type="slidenum">
               <a:rPr lang="en-US" smtClean="0"/>
-              <a:t>‹#›</a:t>
+              <a:t>‹nº›</a:t>
             </a:fld>
             <a:endParaRPr lang="en-US"/>
           </a:p>
@@ -1725,7 +1725,7 @@
           <a:p>
             <a:fld id="{5BCAD085-E8A6-8845-BD4E-CB4CCA059FC4}" type="datetimeFigureOut">
               <a:rPr lang="en-US" smtClean="0"/>
-              <a:t>9/6/2026</a:t>
+              <a:t>9/8/2026</a:t>
             </a:fld>
             <a:endParaRPr lang="en-US"/>
           </a:p>
@@ -1767,7 +1767,7 @@
           <a:p>
             <a:fld id="{C1FF6DA9-008F-8B48-92A6-B652298478BF}" type="slidenum">
               <a:rPr lang="en-US" smtClean="0"/>
-              <a:t>‹#›</a:t>
+              <a:t>‹nº›</a:t>
             </a:fld>
             <a:endParaRPr lang="en-US"/>
           </a:p>
@@ -1893,7 +1893,7 @@
           <a:p>
             <a:fld id="{5BCAD085-E8A6-8845-BD4E-CB4CCA059FC4}" type="datetimeFigureOut">
               <a:rPr lang="en-US" smtClean="0"/>
-              <a:t>9/6/2026</a:t>
+              <a:t>9/8/2026</a:t>
             </a:fld>
             <a:endParaRPr lang="en-US"/>
           </a:p>
@@ -1935,7 +1935,7 @@
           <a:p>
             <a:fld id="{C1FF6DA9-008F-8B48-92A6-B652298478BF}" type="slidenum">
               <a:rPr lang="en-US" smtClean="0"/>
-              <a:t>‹#›</a:t>
+              <a:t>‹nº›</a:t>
             </a:fld>
             <a:endParaRPr lang="en-US"/>
           </a:p>
@@ -2138,7 +2138,7 @@
           <a:p>
             <a:fld id="{5BCAD085-E8A6-8845-BD4E-CB4CCA059FC4}" type="datetimeFigureOut">
               <a:rPr lang="en-US" smtClean="0"/>
-              <a:t>9/6/2026</a:t>
+              <a:t>9/8/2026</a:t>
             </a:fld>
             <a:endParaRPr lang="en-US"/>
           </a:p>
@@ -2180,7 +2180,7 @@
           <a:p>
             <a:fld id="{C1FF6DA9-008F-8B48-92A6-B652298478BF}" type="slidenum">
               <a:rPr lang="en-US" smtClean="0"/>
-              <a:t>‹#›</a:t>
+              <a:t>‹nº›</a:t>
             </a:fld>
             <a:endParaRPr lang="en-US"/>
           </a:p>
@@ -2423,7 +2423,7 @@
           <a:p>
             <a:fld id="{5BCAD085-E8A6-8845-BD4E-CB4CCA059FC4}" type="datetimeFigureOut">
               <a:rPr lang="en-US" smtClean="0"/>
-              <a:t>9/6/2026</a:t>
+              <a:t>9/8/2026</a:t>
             </a:fld>
             <a:endParaRPr lang="en-US"/>
           </a:p>
@@ -2465,7 +2465,7 @@
           <a:p>
             <a:fld id="{C1FF6DA9-008F-8B48-92A6-B652298478BF}" type="slidenum">
               <a:rPr lang="en-US" smtClean="0"/>
-              <a:t>‹#›</a:t>
+              <a:t>‹nº›</a:t>
             </a:fld>
             <a:endParaRPr lang="en-US"/>
           </a:p>
@@ -2842,7 +2842,7 @@
           <a:p>
             <a:fld id="{5BCAD085-E8A6-8845-BD4E-CB4CCA059FC4}" type="datetimeFigureOut">
               <a:rPr lang="en-US" smtClean="0"/>
-              <a:t>9/6/2026</a:t>
+              <a:t>9/8/2026</a:t>
             </a:fld>
             <a:endParaRPr lang="en-US"/>
           </a:p>
@@ -2884,7 +2884,7 @@
           <a:p>
             <a:fld id="{C1FF6DA9-008F-8B48-92A6-B652298478BF}" type="slidenum">
               <a:rPr lang="en-US" smtClean="0"/>
-              <a:t>‹#›</a:t>
+              <a:t>‹nº›</a:t>
             </a:fld>
             <a:endParaRPr lang="en-US"/>
           </a:p>
@@ -2959,7 +2959,7 @@
           <a:p>
             <a:fld id="{5BCAD085-E8A6-8845-BD4E-CB4CCA059FC4}" type="datetimeFigureOut">
               <a:rPr lang="en-US" smtClean="0"/>
-              <a:t>9/6/2026</a:t>
+              <a:t>9/8/2026</a:t>
             </a:fld>
             <a:endParaRPr lang="en-US"/>
           </a:p>
@@ -3001,7 +3001,7 @@
           <a:p>
             <a:fld id="{C1FF6DA9-008F-8B48-92A6-B652298478BF}" type="slidenum">
               <a:rPr lang="en-US" smtClean="0"/>
-              <a:t>‹#›</a:t>
+              <a:t>‹nº›</a:t>
             </a:fld>
             <a:endParaRPr lang="en-US"/>
           </a:p>
@@ -3054,7 +3054,7 @@
           <a:p>
             <a:fld id="{5BCAD085-E8A6-8845-BD4E-CB4CCA059FC4}" type="datetimeFigureOut">
               <a:rPr lang="en-US" smtClean="0"/>
-              <a:t>9/6/2026</a:t>
+              <a:t>9/8/2026</a:t>
             </a:fld>
             <a:endParaRPr lang="en-US"/>
           </a:p>
@@ -3096,7 +3096,7 @@
           <a:p>
             <a:fld id="{C1FF6DA9-008F-8B48-92A6-B652298478BF}" type="slidenum">
               <a:rPr lang="en-US" smtClean="0"/>
-              <a:t>‹#›</a:t>
+              <a:t>‹nº›</a:t>
             </a:fld>
             <a:endParaRPr lang="en-US"/>
           </a:p>
@@ -3329,7 +3329,7 @@
           <a:p>
             <a:fld id="{5BCAD085-E8A6-8845-BD4E-CB4CCA059FC4}" type="datetimeFigureOut">
               <a:rPr lang="en-US" smtClean="0"/>
-              <a:t>9/6/2026</a:t>
+              <a:t>9/8/2026</a:t>
             </a:fld>
             <a:endParaRPr lang="en-US"/>
           </a:p>
@@ -3371,7 +3371,7 @@
           <a:p>
             <a:fld id="{C1FF6DA9-008F-8B48-92A6-B652298478BF}" type="slidenum">
               <a:rPr lang="en-US" smtClean="0"/>
-              <a:t>‹#›</a:t>
+              <a:t>‹nº›</a:t>
             </a:fld>
             <a:endParaRPr lang="en-US"/>
           </a:p>
@@ -3581,7 +3581,7 @@
           <a:p>
             <a:fld id="{5BCAD085-E8A6-8845-BD4E-CB4CCA059FC4}" type="datetimeFigureOut">
               <a:rPr lang="en-US" smtClean="0"/>
-              <a:t>9/6/2026</a:t>
+              <a:t>9/8/2026</a:t>
             </a:fld>
             <a:endParaRPr lang="en-US"/>
           </a:p>
@@ -3623,7 +3623,7 @@
           <a:p>
             <a:fld id="{C1FF6DA9-008F-8B48-92A6-B652298478BF}" type="slidenum">
               <a:rPr lang="en-US" smtClean="0"/>
-              <a:t>‹#›</a:t>
+              <a:t>‹nº›</a:t>
             </a:fld>
             <a:endParaRPr lang="en-US"/>
           </a:p>
@@ -3792,7 +3792,7 @@
           <a:p>
             <a:fld id="{5BCAD085-E8A6-8845-BD4E-CB4CCA059FC4}" type="datetimeFigureOut">
               <a:rPr lang="en-US" smtClean="0"/>
-              <a:t>9/6/2026</a:t>
+              <a:t>9/8/2026</a:t>
             </a:fld>
             <a:endParaRPr lang="en-US"/>
           </a:p>
@@ -3870,7 +3870,7 @@
           <a:p>
             <a:fld id="{C1FF6DA9-008F-8B48-92A6-B652298478BF}" type="slidenum">
               <a:rPr lang="en-US" smtClean="0"/>
-              <a:t>‹#›</a:t>
+              <a:t>‹nº›</a:t>
             </a:fld>
             <a:endParaRPr lang="en-US"/>
           </a:p>
@@ -4168,7 +4168,7 @@
             </a:gs>
           </a:gsLst>
           <a:path path="circle">
-            <a:fillToRect l="38000" t="0" r="62000" b="100000"/>
+            <a:fillToRect l="38000" r="62000" b="100000"/>
           </a:path>
         </a:gradFill>
         <a:effectLst/>
@@ -4247,7 +4247,9 @@
         <p:txBody>
           <a:bodyPr/>
           <a:lstStyle/>
-          <a:p/>
+          <a:p>
+            <a:endParaRPr/>
+          </a:p>
         </p:txBody>
       </p:sp>
       <p:sp>
@@ -4298,7 +4300,9 @@
         <p:txBody>
           <a:bodyPr/>
           <a:lstStyle/>
-          <a:p/>
+          <a:p>
+            <a:endParaRPr/>
+          </a:p>
         </p:txBody>
       </p:sp>
       <p:sp>
@@ -4349,7 +4353,9 @@
         <p:txBody>
           <a:bodyPr/>
           <a:lstStyle/>
-          <a:p/>
+          <a:p>
+            <a:endParaRPr/>
+          </a:p>
         </p:txBody>
       </p:sp>
       <p:sp>
@@ -4376,7 +4382,9 @@
         <p:txBody>
           <a:bodyPr/>
           <a:lstStyle/>
-          <a:p/>
+          <a:p>
+            <a:endParaRPr/>
+          </a:p>
         </p:txBody>
       </p:sp>
       <p:sp>
@@ -4483,7 +4491,9 @@
         <p:txBody>
           <a:bodyPr/>
           <a:lstStyle/>
-          <a:p/>
+          <a:p>
+            <a:endParaRPr/>
+          </a:p>
         </p:txBody>
       </p:sp>
       <p:sp>
@@ -4754,7 +4764,7 @@
           <a:lstStyle/>
           <a:p>
             <a:r>
-              <a:rPr sz="1800" b="1" err="1" i="1">
+              <a:rPr sz="1800" b="1" i="1" err="1">
                 <a:solidFill>
                   <a:srgbClr val="FFB531"/>
                 </a:solidFill>
@@ -4772,7 +4782,7 @@
               <a:t>, no grego: o </a:t>
             </a:r>
             <a:r>
-              <a:rPr sz="1800" b="0" err="1" i="1">
+              <a:rPr sz="1800" b="0" i="1" err="1">
                 <a:solidFill>
                   <a:srgbClr val="BAC6DA"/>
                 </a:solidFill>
@@ -4790,7 +4800,7 @@
               <a:t> </a:t>
             </a:r>
             <a:r>
-              <a:rPr sz="1800" b="0" err="1" i="1">
+              <a:rPr sz="1800" b="0" i="1" err="1">
                 <a:solidFill>
                   <a:srgbClr val="BAC6DA"/>
                 </a:solidFill>
@@ -4808,7 +4818,7 @@
               <a:t> de </a:t>
             </a:r>
             <a:r>
-              <a:rPr sz="1800" b="0" err="1" i="1">
+              <a:rPr sz="1800" b="0" i="1" err="1">
                 <a:solidFill>
                   <a:srgbClr val="BAC6DA"/>
                 </a:solidFill>
@@ -4945,7 +4955,7 @@
             </a:gs>
           </a:gsLst>
           <a:path path="circle">
-            <a:fillToRect l="38000" t="0" r="62000" b="100000"/>
+            <a:fillToRect l="38000" r="62000" b="100000"/>
           </a:path>
         </a:gradFill>
         <a:effectLst/>
@@ -5013,7 +5023,9 @@
         <p:txBody>
           <a:bodyPr/>
           <a:lstStyle/>
-          <a:p/>
+          <a:p>
+            <a:endParaRPr/>
+          </a:p>
         </p:txBody>
       </p:sp>
       <p:sp>
@@ -5064,7 +5076,9 @@
         <p:txBody>
           <a:bodyPr/>
           <a:lstStyle/>
-          <a:p/>
+          <a:p>
+            <a:endParaRPr/>
+          </a:p>
         </p:txBody>
       </p:sp>
       <p:sp>
@@ -5126,7 +5140,9 @@
         <p:txBody>
           <a:bodyPr/>
           <a:lstStyle/>
-          <a:p/>
+          <a:p>
+            <a:endParaRPr/>
+          </a:p>
         </p:txBody>
       </p:sp>
       <p:sp>
@@ -6592,7 +6608,7 @@
             </a:gs>
           </a:gsLst>
           <a:path path="circle">
-            <a:fillToRect l="38000" t="0" r="62000" b="100000"/>
+            <a:fillToRect l="38000" r="62000" b="100000"/>
           </a:path>
         </a:gradFill>
         <a:effectLst/>
@@ -6660,7 +6676,9 @@
         <p:txBody>
           <a:bodyPr/>
           <a:lstStyle/>
-          <a:p/>
+          <a:p>
+            <a:endParaRPr/>
+          </a:p>
         </p:txBody>
       </p:sp>
       <p:sp>
@@ -6711,7 +6729,9 @@
         <p:txBody>
           <a:bodyPr/>
           <a:lstStyle/>
-          <a:p/>
+          <a:p>
+            <a:endParaRPr/>
+          </a:p>
         </p:txBody>
       </p:sp>
       <p:sp>
@@ -6773,7 +6793,9 @@
         <p:txBody>
           <a:bodyPr/>
           <a:lstStyle/>
-          <a:p/>
+          <a:p>
+            <a:endParaRPr/>
+          </a:p>
         </p:txBody>
       </p:sp>
       <p:sp>
@@ -8923,7 +8945,7 @@
             </a:gs>
           </a:gsLst>
           <a:path path="circle">
-            <a:fillToRect l="38000" t="0" r="62000" b="100000"/>
+            <a:fillToRect l="38000" r="62000" b="100000"/>
           </a:path>
         </a:gradFill>
         <a:effectLst/>
@@ -8991,7 +9013,9 @@
         <p:txBody>
           <a:bodyPr/>
           <a:lstStyle/>
-          <a:p/>
+          <a:p>
+            <a:endParaRPr/>
+          </a:p>
         </p:txBody>
       </p:sp>
       <p:sp>
@@ -9042,7 +9066,9 @@
         <p:txBody>
           <a:bodyPr/>
           <a:lstStyle/>
-          <a:p/>
+          <a:p>
+            <a:endParaRPr/>
+          </a:p>
         </p:txBody>
       </p:sp>
       <p:sp>
@@ -9104,7 +9130,9 @@
         <p:txBody>
           <a:bodyPr/>
           <a:lstStyle/>
-          <a:p/>
+          <a:p>
+            <a:endParaRPr/>
+          </a:p>
         </p:txBody>
       </p:sp>
       <p:sp>
@@ -10423,8 +10451,8 @@
           </a:p>
         </p:txBody>
       </p:sp>
-      <mc:AlternateContent xmlns:mc="http://schemas.openxmlformats.org/markup-compatibility/2006">
-        <mc:Choice xmlns:a14="http://schemas.microsoft.com/office/drawing/2010/main" Requires="a14">
+      <mc:AlternateContent xmlns:mc="http://schemas.openxmlformats.org/markup-compatibility/2006" xmlns:a14="http://schemas.microsoft.com/office/drawing/2010/main">
+        <mc:Choice Requires="a14">
           <p:sp>
             <p:nvSpPr>
               <p:cNvPr id="24" name="s4_22"/>
@@ -10460,10 +10488,7 @@
                 </a:pPr>
                 <a14:m>
                   <m:oMathPara xmlns:m="http://schemas.openxmlformats.org/officeDocument/2006/math">
-                    <m:oMathParaPr>
-                      <m:jc m:val="centerGroup"/>
-                    </m:oMathParaPr>
-                    <m:oMath xmlns:m="http://schemas.openxmlformats.org/officeDocument/2006/math">
+                    <m:oMath>
                       <m:r>
                         <a:rPr lang="pt-BR" sz="1400" b="0" i="1" spc="40" dirty="0" smtClean="0">
                           <a:solidFill>
@@ -10615,7 +10640,7 @@
             </p:txBody>
           </p:sp>
         </mc:Choice>
-        <mc:Fallback>
+        <mc:Fallback xmlns="">
           <p:sp>
             <p:nvSpPr>
               <p:cNvPr id="24" name="s4_22"/>
@@ -12157,13 +12182,13 @@
   <p:clrMapOvr>
     <a:masterClrMapping/>
   </p:clrMapOvr>
-  <mc:AlternateContent xmlns:mc="http://schemas.openxmlformats.org/markup-compatibility/2006">
-    <mc:Choice xmlns:p159="http://schemas.microsoft.com/office/powerpoint/2015/09/main" Requires="p159">
+  <mc:AlternateContent xmlns:mc="http://schemas.openxmlformats.org/markup-compatibility/2006" xmlns:p159="http://schemas.microsoft.com/office/powerpoint/2015/09/main">
+    <mc:Choice Requires="p159">
       <p:transition xmlns:p14="http://schemas.microsoft.com/office/powerpoint/2010/main" spd="slow" p14:dur="900">
         <p159:morph option="byObject"/>
       </p:transition>
     </mc:Choice>
-    <mc:Fallback>
+    <mc:Fallback xmlns="">
       <p:transition spd="slow">
         <p:fade/>
       </p:transition>
@@ -12190,7 +12215,7 @@
             </a:gs>
           </a:gsLst>
           <a:path path="circle">
-            <a:fillToRect l="38000" t="0" r="62000" b="100000"/>
+            <a:fillToRect l="38000" r="62000" b="100000"/>
           </a:path>
         </a:gradFill>
         <a:effectLst/>
@@ -12258,7 +12283,9 @@
         <p:txBody>
           <a:bodyPr/>
           <a:lstStyle/>
-          <a:p/>
+          <a:p>
+            <a:endParaRPr/>
+          </a:p>
         </p:txBody>
       </p:sp>
       <p:sp>
@@ -12309,7 +12336,9 @@
         <p:txBody>
           <a:bodyPr/>
           <a:lstStyle/>
-          <a:p/>
+          <a:p>
+            <a:endParaRPr/>
+          </a:p>
         </p:txBody>
       </p:sp>
       <p:sp>
@@ -12371,7 +12400,9 @@
         <p:txBody>
           <a:bodyPr/>
           <a:lstStyle/>
-          <a:p/>
+          <a:p>
+            <a:endParaRPr/>
+          </a:p>
         </p:txBody>
       </p:sp>
       <p:sp>
@@ -14485,13 +14516,13 @@
   <p:clrMapOvr>
     <a:masterClrMapping/>
   </p:clrMapOvr>
-  <mc:AlternateContent xmlns:mc="http://schemas.openxmlformats.org/markup-compatibility/2006">
-    <mc:Choice xmlns:p159="http://schemas.microsoft.com/office/powerpoint/2015/09/main" Requires="p159">
+  <mc:AlternateContent xmlns:mc="http://schemas.openxmlformats.org/markup-compatibility/2006" xmlns:p159="http://schemas.microsoft.com/office/powerpoint/2015/09/main">
+    <mc:Choice Requires="p159">
       <p:transition xmlns:p14="http://schemas.microsoft.com/office/powerpoint/2010/main" spd="slow" p14:dur="900">
         <p159:morph option="byObject"/>
       </p:transition>
     </mc:Choice>
-    <mc:Fallback>
+    <mc:Fallback xmlns="">
       <p:transition spd="slow">
         <p:fade/>
       </p:transition>
@@ -14518,7 +14549,7 @@
             </a:gs>
           </a:gsLst>
           <a:path path="circle">
-            <a:fillToRect l="38000" t="0" r="62000" b="100000"/>
+            <a:fillToRect l="38000" r="62000" b="100000"/>
           </a:path>
         </a:gradFill>
         <a:effectLst/>
@@ -14586,7 +14617,9 @@
         <p:txBody>
           <a:bodyPr/>
           <a:lstStyle/>
-          <a:p/>
+          <a:p>
+            <a:endParaRPr/>
+          </a:p>
         </p:txBody>
       </p:sp>
       <p:sp>
@@ -14637,7 +14670,9 @@
         <p:txBody>
           <a:bodyPr/>
           <a:lstStyle/>
-          <a:p/>
+          <a:p>
+            <a:endParaRPr/>
+          </a:p>
         </p:txBody>
       </p:sp>
       <p:sp>
@@ -14699,7 +14734,9 @@
         <p:txBody>
           <a:bodyPr/>
           <a:lstStyle/>
-          <a:p/>
+          <a:p>
+            <a:endParaRPr/>
+          </a:p>
         </p:txBody>
       </p:sp>
       <p:sp>
@@ -16813,18 +16850,7 @@
                 <a:ea typeface="+mn-lt"/>
                 <a:cs typeface="Bahnschrift SemiLight"/>
               </a:rPr>
-              <a:t>O</a:t>
-            </a:r>
-            <a:r>
-              <a:rPr lang="en-US" sz="1150">
-                <a:solidFill>
-                  <a:srgbClr val="BAC6DA"/>
-                </a:solidFill>
-                <a:latin typeface="Bahnschrift SemiLight"/>
-                <a:ea typeface="+mn-lt"/>
-                <a:cs typeface="Bahnschrift SemiLight"/>
-              </a:rPr>
-              <a:t> </a:t>
+              <a:t>O </a:t>
             </a:r>
             <a:r>
               <a:rPr lang="en-US" sz="1150" b="0" err="1">
@@ -17615,8 +17641,8 @@
           </a:p>
         </p:txBody>
       </p:sp>
-      <mc:AlternateContent xmlns:mc="http://schemas.openxmlformats.org/markup-compatibility/2006">
-        <mc:Choice xmlns:a14="http://schemas.microsoft.com/office/drawing/2010/main" Requires="a14">
+      <mc:AlternateContent xmlns:mc="http://schemas.openxmlformats.org/markup-compatibility/2006" xmlns:a14="http://schemas.microsoft.com/office/drawing/2010/main">
+        <mc:Choice Requires="a14">
           <p:sp>
             <p:nvSpPr>
               <p:cNvPr id="37" name="s6_35"/>
@@ -17652,10 +17678,7 @@
                 </a:pPr>
                 <a14:m>
                   <m:oMathPara xmlns:m="http://schemas.openxmlformats.org/officeDocument/2006/math">
-                    <m:oMathParaPr>
-                      <m:jc m:val="centerGroup"/>
-                    </m:oMathParaPr>
-                    <m:oMath xmlns:m="http://schemas.openxmlformats.org/officeDocument/2006/math">
+                    <m:oMath>
                       <m:r>
                         <a:rPr lang="pt-BR" b="1" i="0" dirty="0" smtClean="0">
                           <a:solidFill>
@@ -17747,7 +17770,7 @@
             </p:txBody>
           </p:sp>
         </mc:Choice>
-        <mc:Fallback>
+        <mc:Fallback xmlns="">
           <p:sp>
             <p:nvSpPr>
               <p:cNvPr id="37" name="s6_35"/>
@@ -17877,13 +17900,13 @@
   <p:clrMapOvr>
     <a:masterClrMapping/>
   </p:clrMapOvr>
-  <mc:AlternateContent xmlns:mc="http://schemas.openxmlformats.org/markup-compatibility/2006">
-    <mc:Choice xmlns:p159="http://schemas.microsoft.com/office/powerpoint/2015/09/main" Requires="p159">
+  <mc:AlternateContent xmlns:mc="http://schemas.openxmlformats.org/markup-compatibility/2006" xmlns:p159="http://schemas.microsoft.com/office/powerpoint/2015/09/main">
+    <mc:Choice Requires="p159">
       <p:transition xmlns:p14="http://schemas.microsoft.com/office/powerpoint/2010/main" spd="slow" p14:dur="900">
         <p159:morph option="byObject"/>
       </p:transition>
     </mc:Choice>
-    <mc:Fallback>
+    <mc:Fallback xmlns="">
       <p:transition spd="slow">
         <p:fade/>
       </p:transition>
@@ -17910,7 +17933,7 @@
             </a:gs>
           </a:gsLst>
           <a:path path="circle">
-            <a:fillToRect l="38000" t="0" r="62000" b="100000"/>
+            <a:fillToRect l="38000" r="62000" b="100000"/>
           </a:path>
         </a:gradFill>
         <a:effectLst/>
@@ -17978,7 +18001,9 @@
         <p:txBody>
           <a:bodyPr/>
           <a:lstStyle/>
-          <a:p/>
+          <a:p>
+            <a:endParaRPr/>
+          </a:p>
         </p:txBody>
       </p:sp>
       <p:sp>
@@ -18029,7 +18054,9 @@
         <p:txBody>
           <a:bodyPr/>
           <a:lstStyle/>
-          <a:p/>
+          <a:p>
+            <a:endParaRPr/>
+          </a:p>
         </p:txBody>
       </p:sp>
       <p:sp>
@@ -18091,7 +18118,9 @@
         <p:txBody>
           <a:bodyPr/>
           <a:lstStyle/>
-          <a:p/>
+          <a:p>
+            <a:endParaRPr/>
+          </a:p>
         </p:txBody>
       </p:sp>
       <p:sp>
@@ -18210,7 +18239,7 @@
               <a:t>   </a:t>
             </a:r>
             <a:r>
-              <a:rPr lang="pt-BR" sz="1100" spc="72" b="0">
+              <a:rPr lang="pt-BR" sz="1100" b="0" spc="72">
                 <a:solidFill>
                   <a:srgbClr val="8395B5"/>
                 </a:solidFill>
@@ -20353,7 +20382,7 @@
             </a:gs>
           </a:gsLst>
           <a:path path="circle">
-            <a:fillToRect l="38000" t="0" r="62000" b="100000"/>
+            <a:fillToRect l="38000" r="62000" b="100000"/>
           </a:path>
         </a:gradFill>
         <a:effectLst/>
@@ -20421,7 +20450,9 @@
         <p:txBody>
           <a:bodyPr/>
           <a:lstStyle/>
-          <a:p/>
+          <a:p>
+            <a:endParaRPr/>
+          </a:p>
         </p:txBody>
       </p:sp>
       <p:sp>
@@ -20472,7 +20503,9 @@
         <p:txBody>
           <a:bodyPr/>
           <a:lstStyle/>
-          <a:p/>
+          <a:p>
+            <a:endParaRPr/>
+          </a:p>
         </p:txBody>
       </p:sp>
       <p:sp>
@@ -20534,7 +20567,9 @@
         <p:txBody>
           <a:bodyPr/>
           <a:lstStyle/>
-          <a:p/>
+          <a:p>
+            <a:endParaRPr/>
+          </a:p>
         </p:txBody>
       </p:sp>
       <p:sp>
@@ -22570,7 +22605,7 @@
             </a:gs>
           </a:gsLst>
           <a:path path="circle">
-            <a:fillToRect l="38000" t="0" r="62000" b="100000"/>
+            <a:fillToRect l="38000" r="62000" b="100000"/>
           </a:path>
         </a:gradFill>
         <a:effectLst/>
@@ -22649,7 +22684,9 @@
         <p:txBody>
           <a:bodyPr/>
           <a:lstStyle/>
-          <a:p/>
+          <a:p>
+            <a:endParaRPr/>
+          </a:p>
         </p:txBody>
       </p:sp>
       <p:sp>
@@ -22700,7 +22737,9 @@
         <p:txBody>
           <a:bodyPr/>
           <a:lstStyle/>
-          <a:p/>
+          <a:p>
+            <a:endParaRPr/>
+          </a:p>
         </p:txBody>
       </p:sp>
       <p:sp>
@@ -22751,7 +22790,9 @@
         <p:txBody>
           <a:bodyPr/>
           <a:lstStyle/>
-          <a:p/>
+          <a:p>
+            <a:endParaRPr/>
+          </a:p>
         </p:txBody>
       </p:sp>
       <p:sp>
@@ -22778,7 +22819,9 @@
         <p:txBody>
           <a:bodyPr/>
           <a:lstStyle/>
-          <a:p/>
+          <a:p>
+            <a:endParaRPr/>
+          </a:p>
         </p:txBody>
       </p:sp>
       <p:sp>
@@ -22885,7 +22928,9 @@
         <p:txBody>
           <a:bodyPr/>
           <a:lstStyle/>
-          <a:p/>
+          <a:p>
+            <a:endParaRPr/>
+          </a:p>
         </p:txBody>
       </p:sp>
       <p:sp>
@@ -23091,7 +23136,7 @@
         <p:nvSpPr>
           <p:cNvPr id="8" name="TextBox 7">
             <a:extLst>
-              <a:ext uri="{FF2B5EF4-FFF2-40B4-BE49-F238E27FC236}" cy="900000">
+              <a:ext uri="{FF2B5EF4-FFF2-40B4-BE49-F238E27FC236}">
                 <a16:creationId xmlns:a16="http://schemas.microsoft.com/office/drawing/2014/main" id="{BB5290D6-2EB0-BB5D-D448-220E46A92B64}"/>
               </a:ext>
             </a:extLst>
@@ -23156,7 +23201,7 @@
           <a:lstStyle/>
           <a:p>
             <a:r>
-              <a:rPr sz="1800" b="1" err="1" i="1">
+              <a:rPr sz="1800" b="1" i="1" err="1">
                 <a:solidFill>
                   <a:srgbClr val="FFB531"/>
                 </a:solidFill>
@@ -23173,12 +23218,6 @@
               </a:rPr>
               <a:t>: a carteira só se move quando a probabilidade se move. Obrigado pela oportunidade.</a:t>
             </a:r>
-            <a:endParaRPr sz="1800" b="0" i="1">
-              <a:solidFill>
-                <a:srgbClr val="BAC6DA"/>
-              </a:solidFill>
-              <a:latin typeface="Georgia"/>
-            </a:endParaRPr>
           </a:p>
         </p:txBody>
       </p:sp>

</xml_diff>